<commit_message>
Presentación compatible con visores móviles
Fotos recortadas de antemano y colores fijos para que se vea igual en iPhone;
ajustes en las diapositivas 4 y 6.

Co-Authored-By: Claude Opus 5.5 <noreply@anthropic.com>
Claude-Session: https://claude.ai/code/session_01EYd8j6jaTfGGnYZUrfHhtJ
</commit_message>
<xml_diff>
--- a/Angely_Osorio_SO_C2_E133_Exposicion.pptx
+++ b/Angely_Osorio_SO_C2_E133_Exposicion.pptx
@@ -114,22 +114,22 @@
   <p:extLst>
     <p:ext uri="{521415D9-36F7-43E2-AB2F-B90AF26B5E84}">
       <p14:sectionLst xmlns:p14="http://schemas.microsoft.com/office/powerpoint/2010/main">
-        <p14:section name="Portada" id="{f1c13b00-a425-e926-042e-5e6c14114499}">
+        <p14:section name="Portada" id="{1af674cd-4ff3-5b9d-83e2-8ea83437d380}">
           <p14:sldIdLst>
             <p14:sldId id="256"/>
           </p14:sldIdLst>
         </p14:section>
-        <p14:section name="Introducción" id="{876b26c7-1be3-7c5b-fac0-f9de5ae26d2c}">
+        <p14:section name="Introducción" id="{b07616c9-c8c6-b08c-8331-da97c1bc2888}">
           <p14:sldIdLst>
             <p14:sldId id="257"/>
           </p14:sldIdLst>
         </p14:section>
-        <p14:section name="Método" id="{e2457070-6b6b-732a-a367-88e94270878b}">
+        <p14:section name="Método" id="{d491deb5-4c44-3919-bd10-fbfdea97a9d8}">
           <p14:sldIdLst>
             <p14:sldId id="258"/>
           </p14:sldIdLst>
         </p14:section>
-        <p14:section name="Resultados" id="{693dc496-5047-0363-8108-7dc03517eb8a}">
+        <p14:section name="Resultados" id="{bd24252c-0133-68d8-b03c-5af212859b8f}">
           <p14:sldIdLst>
             <p14:sldId id="259"/>
             <p14:sldId id="260"/>
@@ -137,7 +137,7 @@
             <p14:sldId id="262"/>
           </p14:sldIdLst>
         </p14:section>
-        <p14:section name="Conclusión" id="{75206cd3-f2a1-7594-ea87-87693cc75b2e}">
+        <p14:section name="Conclusión" id="{729450eb-948a-5d58-b91c-b12e9d5be1b0}">
           <p14:sldIdLst>
             <p14:sldId id="263"/>
           </p14:sldIdLst>
@@ -1637,7 +1637,7 @@
     <p:bg>
       <p:bgPr>
         <a:solidFill>
-          <a:schemeClr val="tx2"/>
+          <a:srgbClr val="3B3B3B"/>
         </a:solidFill>
       </p:bgPr>
     </p:bg>
@@ -1669,7 +1669,7 @@
     <p:bg>
       <p:bgPr>
         <a:solidFill>
-          <a:schemeClr val="bg1"/>
+          <a:srgbClr val="FFFFFF"/>
         </a:solidFill>
       </p:bgPr>
     </p:bg>
@@ -1738,7 +1738,7 @@
             <a:r>
               <a:rPr lang="en-US" sz="1000" dirty="0">
                 <a:solidFill>
-                  <a:schemeClr val="accent6"/>
+                  <a:srgbClr val="5F5F5F"/>
                 </a:solidFill>
               </a:rPr>
               <a:t>Evaluación MESERI · CEDI D1 Lebrija</a:t>
@@ -1773,7 +1773,7 @@
               <a:buNone/>
               <a:defRPr lang="en-US" sz="3200" b="1" dirty="0">
                 <a:solidFill>
-                  <a:schemeClr val="tx1"/>
+                  <a:srgbClr val="2E2E2E"/>
                 </a:solidFill>
               </a:defRPr>
             </a:lvl1pPr>
@@ -1816,7 +1816,7 @@
             <a:lvl1pPr>
               <a:defRPr sz="1000">
                 <a:solidFill>
-                  <a:schemeClr val="accent6"/>
+                  <a:srgbClr val="5F5F5F"/>
                 </a:solidFill>
               </a:defRPr>
             </a:lvl1pPr>
@@ -1845,7 +1845,7 @@
     <p:bg>
       <p:bgPr>
         <a:solidFill>
-          <a:schemeClr val="tx2"/>
+          <a:srgbClr val="3B3B3B"/>
         </a:solidFill>
       </p:bgPr>
     </p:bg>
@@ -1889,7 +1889,7 @@
               <a:buNone/>
               <a:defRPr lang="en-US" sz="3200" b="1" dirty="0">
                 <a:solidFill>
-                  <a:schemeClr val="bg1"/>
+                  <a:srgbClr val="FFFFFF"/>
                 </a:solidFill>
               </a:defRPr>
             </a:lvl1pPr>
@@ -1932,7 +1932,7 @@
             <a:lvl1pPr>
               <a:defRPr sz="1000">
                 <a:solidFill>
-                  <a:schemeClr val="accent1"/>
+                  <a:srgbClr val="CAD225"/>
                 </a:solidFill>
               </a:defRPr>
             </a:lvl1pPr>
@@ -2002,7 +2002,7 @@
             <a:lvl1pPr>
               <a:defRPr sz="1000">
                 <a:solidFill>
-                  <a:schemeClr val="accent6"/>
+                  <a:srgbClr val="5F5F5F"/>
                 </a:solidFill>
               </a:defRPr>
             </a:lvl1pPr>
@@ -2299,7 +2299,7 @@
       </p:grpSpPr>
       <p:pic>
         <p:nvPicPr>
-          <p:cNvPr id="2" name="foto fachada" descr="/tmp/claude-0/-home-user-cedi-d1-lebrija/46e3a16f-f43b-510e-9032-e476e8d715c5/scratchpad/assets/f_27.jpg">    </p:cNvPr>
+          <p:cNvPr id="2" name="foto fachada" descr="/tmp/claude-0/-home-user-cedi-d1-lebrija/46e3a16f-f43b-510e-9032-e476e8d715c5/scratchpad/ppt/recortes/27_6.33x7.5.jpg">    </p:cNvPr>
           <p:cNvPicPr>
             <a:picLocks noChangeAspect="1"/>
           </p:cNvPicPr>
@@ -2307,8 +2307,9 @@
         </p:nvPicPr>
         <p:blipFill>
           <a:blip r:embed="rId1"/>
-          <a:srcRect l="0" r="0" t="0" b="0"/>
-          <a:stretch/>
+          <a:stretch>
+            <a:fillRect/>
+          </a:stretch>
         </p:blipFill>
         <p:spPr>
           <a:xfrm>
@@ -2371,7 +2372,7 @@
             <a:r>
               <a:rPr lang="en-US" sz="3800" b="1" dirty="0">
                 <a:solidFill>
-                  <a:schemeClr val="bg1"/>
+                  <a:srgbClr val="FFFFFF"/>
                 </a:solidFill>
               </a:rPr>
               <a:t>Evaluación de Riesgos de Incendio</a:t>
@@ -2407,7 +2408,7 @@
             <a:r>
               <a:rPr lang="en-US" sz="2000" dirty="0">
                 <a:solidFill>
-                  <a:schemeClr val="accent1"/>
+                  <a:srgbClr val="CAD225"/>
                 </a:solidFill>
               </a:rPr>
               <a:t>Método MESERI · CEDI D1 Lebrija, Santander</a:t>
@@ -2446,7 +2447,7 @@
             <a:r>
               <a:rPr lang="en-US" sz="1500" b="1" dirty="0">
                 <a:solidFill>
-                  <a:schemeClr val="bg1"/>
+                  <a:srgbClr val="FFFFFF"/>
                 </a:solidFill>
               </a:rPr>
               <a:t>Angely Tatiana Osorio Sánchez</a:t>
@@ -2463,7 +2464,7 @@
             <a:r>
               <a:rPr lang="en-US" sz="1500" dirty="0">
                 <a:solidFill>
-                  <a:schemeClr val="bg1"/>
+                  <a:srgbClr val="FFFFFF"/>
                 </a:solidFill>
               </a:rPr>
               <a:t>Profesor: Jhonny Mauricio Ceron Cifuentes</a:t>
@@ -2480,7 +2481,7 @@
             <a:r>
               <a:rPr lang="en-US" sz="1500" dirty="0">
                 <a:solidFill>
-                  <a:schemeClr val="bg1"/>
+                  <a:srgbClr val="FFFFFF"/>
                 </a:solidFill>
               </a:rPr>
               <a:t>Electiva Complementaria Salud Ocupacional – Grupo E133</a:t>
@@ -2497,7 +2498,7 @@
             <a:r>
               <a:rPr lang="en-US" sz="1500" dirty="0">
                 <a:solidFill>
-                  <a:schemeClr val="bg1"/>
+                  <a:srgbClr val="FFFFFF"/>
                 </a:solidFill>
               </a:rPr>
               <a:t>Unidades Tecnológicas de Santander · Octubre de 2026</a:t>
@@ -2560,7 +2561,7 @@
             <a:r>
               <a:rPr lang="en-US" sz="3200" b="1" dirty="0">
                 <a:solidFill>
-                  <a:schemeClr val="tx1"/>
+                  <a:srgbClr val="2E2E2E"/>
                 </a:solidFill>
               </a:rPr>
               <a:t>El Centro de Distribución evaluado</a:t>
@@ -2571,7 +2572,7 @@
       </p:sp>
       <p:pic>
         <p:nvPicPr>
-          <p:cNvPr id="3" name="foto almacén" descr="/tmp/claude-0/-home-user-cedi-d1-lebrija/46e3a16f-f43b-510e-9032-e476e8d715c5/scratchpad/assets/n_4.jpg">    </p:cNvPr>
+          <p:cNvPr id="3" name="foto almacén" descr="/tmp/claude-0/-home-user-cedi-d1-lebrija/46e3a16f-f43b-510e-9032-e476e8d715c5/scratchpad/ppt/recortes/n_4_6.2x4.65.jpg">    </p:cNvPr>
           <p:cNvPicPr>
             <a:picLocks noChangeAspect="1"/>
           </p:cNvPicPr>
@@ -2579,8 +2580,9 @@
         </p:nvPicPr>
         <p:blipFill>
           <a:blip r:embed="rId1"/>
-          <a:srcRect l="0" r="0" t="0" b="0"/>
-          <a:stretch/>
+          <a:stretch>
+            <a:fillRect/>
+          </a:stretch>
         </p:blipFill>
         <p:spPr>
           <a:xfrm>
@@ -2619,7 +2621,7 @@
             <a:r>
               <a:rPr lang="en-US" sz="1100" i="1" dirty="0">
                 <a:solidFill>
-                  <a:schemeClr val="accent6"/>
+                  <a:srgbClr val="5F5F5F"/>
                 </a:solidFill>
               </a:rPr>
               <a:t>Bodega vista desde el mezanine de oficinas</a:t>
@@ -2645,11 +2647,11 @@
             </a:avLst>
           </a:prstGeom>
           <a:solidFill>
-            <a:schemeClr val="bg2"/>
+            <a:srgbClr val="F4F7D3"/>
           </a:solidFill>
           <a:ln w="12700">
             <a:solidFill>
-              <a:schemeClr val="bg2"/>
+              <a:srgbClr val="F4F7D3"/>
             </a:solidFill>
             <a:prstDash val="solid"/>
           </a:ln>
@@ -2689,7 +2691,7 @@
             <a:r>
               <a:rPr lang="en-US" sz="3000" b="1" dirty="0">
                 <a:solidFill>
-                  <a:schemeClr val="tx1"/>
+                  <a:srgbClr val="2E2E2E"/>
                 </a:solidFill>
               </a:rPr>
               <a:t>17.432 m²</a:t>
@@ -2725,7 +2727,7 @@
             <a:r>
               <a:rPr lang="en-US" sz="1400" dirty="0">
                 <a:solidFill>
-                  <a:schemeClr val="accent6"/>
+                  <a:srgbClr val="5F5F5F"/>
                 </a:solidFill>
               </a:rPr>
               <a:t>Área en un solo sector</a:t>
@@ -2751,11 +2753,11 @@
             </a:avLst>
           </a:prstGeom>
           <a:solidFill>
-            <a:schemeClr val="bg2"/>
+            <a:srgbClr val="F4F7D3"/>
           </a:solidFill>
           <a:ln w="12700">
             <a:solidFill>
-              <a:schemeClr val="bg2"/>
+              <a:srgbClr val="F4F7D3"/>
             </a:solidFill>
             <a:prstDash val="solid"/>
           </a:ln>
@@ -2795,7 +2797,7 @@
             <a:r>
               <a:rPr lang="en-US" sz="3000" b="1" dirty="0">
                 <a:solidFill>
-                  <a:schemeClr val="tx1"/>
+                  <a:srgbClr val="2E2E2E"/>
                 </a:solidFill>
               </a:rPr>
               <a:t>18 m</a:t>
@@ -2831,7 +2833,7 @@
             <a:r>
               <a:rPr lang="en-US" sz="1400" dirty="0">
                 <a:solidFill>
-                  <a:schemeClr val="accent6"/>
+                  <a:srgbClr val="5F5F5F"/>
                 </a:solidFill>
               </a:rPr>
               <a:t>Altura del edificio</a:t>
@@ -2857,11 +2859,11 @@
             </a:avLst>
           </a:prstGeom>
           <a:solidFill>
-            <a:schemeClr val="bg2"/>
+            <a:srgbClr val="F4F7D3"/>
           </a:solidFill>
           <a:ln w="12700">
             <a:solidFill>
-              <a:schemeClr val="bg2"/>
+              <a:srgbClr val="F4F7D3"/>
             </a:solidFill>
             <a:prstDash val="solid"/>
           </a:ln>
@@ -2901,7 +2903,7 @@
             <a:r>
               <a:rPr lang="en-US" sz="3000" b="1" dirty="0">
                 <a:solidFill>
-                  <a:schemeClr val="tx1"/>
+                  <a:srgbClr val="2E2E2E"/>
                 </a:solidFill>
               </a:rPr>
               <a:t>≈ 10 m</a:t>
@@ -2937,7 +2939,7 @@
             <a:r>
               <a:rPr lang="en-US" sz="1400" dirty="0">
                 <a:solidFill>
-                  <a:schemeClr val="accent6"/>
+                  <a:srgbClr val="5F5F5F"/>
                 </a:solidFill>
               </a:rPr>
               <a:t>Altura de las estanterías</a:t>
@@ -2963,11 +2965,11 @@
             </a:avLst>
           </a:prstGeom>
           <a:solidFill>
-            <a:schemeClr val="bg2"/>
+            <a:srgbClr val="F4F7D3"/>
           </a:solidFill>
           <a:ln w="12700">
             <a:solidFill>
-              <a:schemeClr val="bg2"/>
+              <a:srgbClr val="F4F7D3"/>
             </a:solidFill>
             <a:prstDash val="solid"/>
           </a:ln>
@@ -3007,7 +3009,7 @@
             <a:r>
               <a:rPr lang="en-US" sz="3000" b="1" dirty="0">
                 <a:solidFill>
-                  <a:schemeClr val="tx1"/>
+                  <a:srgbClr val="2E2E2E"/>
                 </a:solidFill>
               </a:rPr>
               <a:t>$500.000 M</a:t>
@@ -3043,7 +3045,7 @@
             <a:r>
               <a:rPr lang="en-US" sz="1400" dirty="0">
                 <a:solidFill>
-                  <a:schemeClr val="accent6"/>
+                  <a:srgbClr val="5F5F5F"/>
                 </a:solidFill>
               </a:rPr>
               <a:t>Valor del inventario (COP)</a:t>
@@ -3079,7 +3081,7 @@
             <a:r>
               <a:rPr lang="en-US" sz="1400" dirty="0">
                 <a:solidFill>
-                  <a:schemeClr val="tx1"/>
+                  <a:srgbClr val="2E2E2E"/>
                 </a:solidFill>
               </a:rPr>
               <a:t>Tiendas D1 – Koba Colombia S.A.S. · Sector San Pablo, Lebrija. Bodega con estanterías, cava de frío, muelles y mezanine con oficinas y comedor.</a:t>
@@ -3118,7 +3120,7 @@
             <a:lvl1pPr>
               <a:defRPr sz="1000">
                 <a:solidFill>
-                  <a:schemeClr val="accent6"/>
+                  <a:srgbClr val="5F5F5F"/>
                 </a:solidFill>
               </a:defRPr>
             </a:lvl1pPr>
@@ -3187,7 +3189,7 @@
             <a:r>
               <a:rPr lang="en-US" sz="3200" b="1" dirty="0">
                 <a:solidFill>
-                  <a:schemeClr val="tx1"/>
+                  <a:srgbClr val="2E2E2E"/>
                 </a:solidFill>
               </a:rPr>
               <a:t>¿Cómo funciona el método MESERI?</a:t>
@@ -3213,11 +3215,11 @@
             </a:avLst>
           </a:prstGeom>
           <a:solidFill>
-            <a:schemeClr val="tx2"/>
+            <a:srgbClr val="3B3B3B"/>
           </a:solidFill>
           <a:ln w="12700">
             <a:solidFill>
-              <a:schemeClr val="tx2"/>
+              <a:srgbClr val="3B3B3B"/>
             </a:solidFill>
             <a:prstDash val="solid"/>
           </a:ln>
@@ -3257,7 +3259,7 @@
             <a:r>
               <a:rPr lang="en-US" sz="3600" b="1" dirty="0">
                 <a:solidFill>
-                  <a:schemeClr val="accent1"/>
+                  <a:srgbClr val="CAD225"/>
                 </a:solidFill>
               </a:rPr>
               <a:t>P</a:t>
@@ -3268,7 +3270,7 @@
             <a:r>
               <a:rPr lang="en-US" sz="3600" b="1" dirty="0">
                 <a:solidFill>
-                  <a:schemeClr val="bg1"/>
+                  <a:srgbClr val="FFFFFF"/>
                 </a:solidFill>
               </a:rPr>
               <a:t>  =  5X / 129  +  5Y / 26  +  BCI</a:t>
@@ -3292,11 +3294,11 @@
             <a:avLst/>
           </a:prstGeom>
           <a:solidFill>
-            <a:schemeClr val="accent1"/>
+            <a:srgbClr val="CAD225"/>
           </a:solidFill>
           <a:ln w="12700">
             <a:solidFill>
-              <a:schemeClr val="accent1"/>
+              <a:srgbClr val="CAD225"/>
             </a:solidFill>
             <a:prstDash val="solid"/>
           </a:ln>
@@ -3353,7 +3355,7 @@
             <a:r>
               <a:rPr lang="en-US" sz="1800" b="1" dirty="0">
                 <a:solidFill>
-                  <a:schemeClr val="tx1"/>
+                  <a:srgbClr val="2E2E2E"/>
                 </a:solidFill>
               </a:rPr>
               <a:t>X · Factores propios</a:t>
@@ -3389,7 +3391,7 @@
             <a:r>
               <a:rPr lang="en-US" sz="1400" dirty="0">
                 <a:solidFill>
-                  <a:schemeClr val="accent6"/>
+                  <a:srgbClr val="5F5F5F"/>
                 </a:solidFill>
               </a:rPr>
               <a:t>Construcción, situación, procesos, concentración, propagabilidad y destructibilidad. Máximo 129 puntos.</a:t>
@@ -3413,11 +3415,11 @@
             <a:avLst/>
           </a:prstGeom>
           <a:solidFill>
-            <a:schemeClr val="accent1"/>
+            <a:srgbClr val="CAD225"/>
           </a:solidFill>
           <a:ln w="12700">
             <a:solidFill>
-              <a:schemeClr val="accent1"/>
+              <a:srgbClr val="CAD225"/>
             </a:solidFill>
             <a:prstDash val="solid"/>
           </a:ln>
@@ -3474,7 +3476,7 @@
             <a:r>
               <a:rPr lang="en-US" sz="1800" b="1" dirty="0">
                 <a:solidFill>
-                  <a:schemeClr val="tx1"/>
+                  <a:srgbClr val="2E2E2E"/>
                 </a:solidFill>
               </a:rPr>
               <a:t>Y · Protección</a:t>
@@ -3510,7 +3512,7 @@
             <a:r>
               <a:rPr lang="en-US" sz="1400" dirty="0">
                 <a:solidFill>
-                  <a:schemeClr val="accent6"/>
+                  <a:srgbClr val="5F5F5F"/>
                 </a:solidFill>
               </a:rPr>
               <a:t>Extintores, gabinetes, hidrantes, detección, rociadores y agentes gaseosos. Máximo 26 puntos.</a:t>
@@ -3534,11 +3536,11 @@
             <a:avLst/>
           </a:prstGeom>
           <a:solidFill>
-            <a:schemeClr val="accent1"/>
+            <a:srgbClr val="CAD225"/>
           </a:solidFill>
           <a:ln w="12700">
             <a:solidFill>
-              <a:schemeClr val="accent1"/>
+              <a:srgbClr val="CAD225"/>
             </a:solidFill>
             <a:prstDash val="solid"/>
           </a:ln>
@@ -3595,7 +3597,7 @@
             <a:r>
               <a:rPr lang="en-US" sz="1800" b="1" dirty="0">
                 <a:solidFill>
-                  <a:schemeClr val="tx1"/>
+                  <a:srgbClr val="2E2E2E"/>
                 </a:solidFill>
               </a:rPr>
               <a:t>BCI · Brigada</a:t>
@@ -3631,7 +3633,7 @@
             <a:r>
               <a:rPr lang="en-US" sz="1400" dirty="0">
                 <a:solidFill>
-                  <a:schemeClr val="accent6"/>
+                  <a:srgbClr val="5F5F5F"/>
                 </a:solidFill>
               </a:rPr>
               <a:t>Suma 1 punto si existe una brigada contra incendios; si no, 0.</a:t>
@@ -3667,7 +3669,7 @@
             <a:r>
               <a:rPr lang="en-US" sz="1400" b="1" dirty="0">
                 <a:solidFill>
-                  <a:schemeClr val="tx1"/>
+                  <a:srgbClr val="2E2E2E"/>
                 </a:solidFill>
               </a:rPr>
               <a:t>P va de 0 a 10: mientras más alto, más protegido está el lugar. Desde 5 es aceptable.</a:t>
@@ -3693,11 +3695,11 @@
             </a:avLst>
           </a:prstGeom>
           <a:solidFill>
-            <a:schemeClr val="accent3"/>
+            <a:srgbClr val="E8836F"/>
           </a:solidFill>
           <a:ln w="12700">
             <a:solidFill>
-              <a:schemeClr val="accent3"/>
+              <a:srgbClr val="E8836F"/>
             </a:solidFill>
             <a:prstDash val="solid"/>
           </a:ln>
@@ -3730,7 +3732,7 @@
             <a:r>
               <a:rPr lang="en-US" sz="1800" b="1" dirty="0">
                 <a:solidFill>
-                  <a:schemeClr val="tx1"/>
+                  <a:srgbClr val="2E2E2E"/>
                 </a:solidFill>
               </a:rPr>
               <a:t>Menos de 3</a:t>
@@ -3744,7 +3746,7 @@
             <a:r>
               <a:rPr lang="en-US" sz="1400" dirty="0">
                 <a:solidFill>
-                  <a:schemeClr val="tx1"/>
+                  <a:srgbClr val="2E2E2E"/>
                 </a:solidFill>
               </a:rPr>
               <a:t>Muy malo</a:t>
@@ -3770,11 +3772,11 @@
             </a:avLst>
           </a:prstGeom>
           <a:solidFill>
-            <a:schemeClr val="accent4"/>
+            <a:srgbClr val="F2B76B"/>
           </a:solidFill>
           <a:ln w="12700">
             <a:solidFill>
-              <a:schemeClr val="accent4"/>
+              <a:srgbClr val="F2B76B"/>
             </a:solidFill>
             <a:prstDash val="solid"/>
           </a:ln>
@@ -3807,7 +3809,7 @@
             <a:r>
               <a:rPr lang="en-US" sz="1800" b="1" dirty="0">
                 <a:solidFill>
-                  <a:schemeClr val="tx1"/>
+                  <a:srgbClr val="2E2E2E"/>
                 </a:solidFill>
               </a:rPr>
               <a:t>3 a 5</a:t>
@@ -3821,7 +3823,7 @@
             <a:r>
               <a:rPr lang="en-US" sz="1400" dirty="0">
                 <a:solidFill>
-                  <a:schemeClr val="tx1"/>
+                  <a:srgbClr val="2E2E2E"/>
                 </a:solidFill>
               </a:rPr>
               <a:t>Malo</a:t>
@@ -3847,11 +3849,11 @@
             </a:avLst>
           </a:prstGeom>
           <a:solidFill>
-            <a:schemeClr val="bg2"/>
+            <a:srgbClr val="F4F7D3"/>
           </a:solidFill>
           <a:ln w="12700">
             <a:solidFill>
-              <a:schemeClr val="bg2"/>
+              <a:srgbClr val="F4F7D3"/>
             </a:solidFill>
             <a:prstDash val="solid"/>
           </a:ln>
@@ -3884,7 +3886,7 @@
             <a:r>
               <a:rPr lang="en-US" sz="1800" b="1" dirty="0">
                 <a:solidFill>
-                  <a:schemeClr val="tx1"/>
+                  <a:srgbClr val="2E2E2E"/>
                 </a:solidFill>
               </a:rPr>
               <a:t>5 a 8</a:t>
@@ -3898,7 +3900,7 @@
             <a:r>
               <a:rPr lang="en-US" sz="1400" dirty="0">
                 <a:solidFill>
-                  <a:schemeClr val="tx1"/>
+                  <a:srgbClr val="2E2E2E"/>
                 </a:solidFill>
               </a:rPr>
               <a:t>Bueno</a:t>
@@ -3924,11 +3926,11 @@
             </a:avLst>
           </a:prstGeom>
           <a:solidFill>
-            <a:schemeClr val="accent1"/>
+            <a:srgbClr val="CAD225"/>
           </a:solidFill>
           <a:ln w="12700">
             <a:solidFill>
-              <a:schemeClr val="accent1"/>
+              <a:srgbClr val="CAD225"/>
             </a:solidFill>
             <a:prstDash val="solid"/>
           </a:ln>
@@ -3961,7 +3963,7 @@
             <a:r>
               <a:rPr lang="en-US" sz="1800" b="1" dirty="0">
                 <a:solidFill>
-                  <a:schemeClr val="tx1"/>
+                  <a:srgbClr val="2E2E2E"/>
                 </a:solidFill>
               </a:rPr>
               <a:t>Más de 8</a:t>
@@ -3975,7 +3977,7 @@
             <a:r>
               <a:rPr lang="en-US" sz="1400" dirty="0">
                 <a:solidFill>
-                  <a:schemeClr val="tx1"/>
+                  <a:srgbClr val="2E2E2E"/>
                 </a:solidFill>
               </a:rPr>
               <a:t>Muy bueno</a:t>
@@ -4014,7 +4016,7 @@
             <a:lvl1pPr>
               <a:defRPr sz="1000">
                 <a:solidFill>
-                  <a:schemeClr val="accent6"/>
+                  <a:srgbClr val="5F5F5F"/>
                 </a:solidFill>
               </a:defRPr>
             </a:lvl1pPr>
@@ -4083,7 +4085,7 @@
             <a:r>
               <a:rPr lang="en-US" sz="3200" b="1" dirty="0">
                 <a:solidFill>
-                  <a:schemeClr val="tx1"/>
+                  <a:srgbClr val="2E2E2E"/>
                 </a:solidFill>
               </a:rPr>
               <a:t>Factores propios del edificio</a:t>
@@ -4125,11 +4127,11 @@
             </a:avLst>
           </a:prstGeom>
           <a:solidFill>
-            <a:schemeClr val="bg2"/>
+            <a:srgbClr val="F4F7D3"/>
           </a:solidFill>
           <a:ln w="12700">
             <a:solidFill>
-              <a:schemeClr val="bg2"/>
+              <a:srgbClr val="F4F7D3"/>
             </a:solidFill>
             <a:prstDash val="solid"/>
           </a:ln>
@@ -4169,7 +4171,7 @@
             <a:r>
               <a:rPr lang="en-US" sz="6600" b="1" dirty="0">
                 <a:solidFill>
-                  <a:schemeClr val="tx1"/>
+                  <a:srgbClr val="2E2E2E"/>
                 </a:solidFill>
               </a:rPr>
               <a:t>57</a:t>
@@ -4180,7 +4182,7 @@
             <a:r>
               <a:rPr lang="en-US" sz="2400" dirty="0">
                 <a:solidFill>
-                  <a:schemeClr val="accent6"/>
+                  <a:srgbClr val="5F5F5F"/>
                 </a:solidFill>
               </a:rPr>
               <a:t> / 129</a:t>
@@ -4216,7 +4218,7 @@
             <a:r>
               <a:rPr lang="en-US" sz="1400" dirty="0">
                 <a:solidFill>
-                  <a:schemeClr val="accent6"/>
+                  <a:srgbClr val="5F5F5F"/>
                 </a:solidFill>
               </a:rPr>
               <a:t>Total X · factores propios</a:t>
@@ -4234,7 +4236,7 @@
         <p:spPr>
           <a:xfrm>
             <a:off x="7863840" y="3657600"/>
-            <a:ext cx="3776472" cy="2194560"/>
+            <a:ext cx="3776472" cy="2468880"/>
           </a:xfrm>
           <a:prstGeom prst="rect">
             <a:avLst/>
@@ -4255,7 +4257,7 @@
             <a:r>
               <a:rPr lang="en-US" sz="1600" b="1" dirty="0">
                 <a:solidFill>
-                  <a:schemeClr val="tx1"/>
+                  <a:srgbClr val="2E2E2E"/>
                 </a:solidFill>
               </a:rPr>
               <a:t>El edificio por sí solo es desfavorable.</a:t>
@@ -4272,10 +4274,27 @@
             <a:r>
               <a:rPr lang="en-US" sz="1600" dirty="0">
                 <a:solidFill>
-                  <a:schemeClr val="tx1"/>
+                  <a:srgbClr val="2E2E2E"/>
                 </a:solidFill>
               </a:rPr>
               <a:t>Su mayor ventaja es la cercanía de los bomberos: 3,4 km y 5 minutos (Situación 15 de 15).</a:t>
+            </a:r>
+            <a:endParaRPr lang="en-US" sz="1600" dirty="0"/>
+          </a:p>
+          <a:p>
+            <a:pPr indent="0" marL="0">
+              <a:spcAft>
+                <a:spcPts val="800"/>
+              </a:spcAft>
+              <a:buNone/>
+            </a:pPr>
+            <a:r>
+              <a:rPr lang="en-US" sz="1600" dirty="0">
+                <a:solidFill>
+                  <a:srgbClr val="5F5F5F"/>
+                </a:solidFill>
+              </a:rPr>
+              <a:t>Seis factores obtuvieron 0: sector de incendio, carga térmica, almacenamiento en altura, concentración, calor y humo.</a:t>
             </a:r>
             <a:endParaRPr lang="en-US" sz="1600" dirty="0"/>
           </a:p>
@@ -4311,7 +4330,7 @@
             <a:lvl1pPr>
               <a:defRPr sz="1000">
                 <a:solidFill>
-                  <a:schemeClr val="accent6"/>
+                  <a:srgbClr val="5F5F5F"/>
                 </a:solidFill>
               </a:defRPr>
             </a:lvl1pPr>
@@ -4380,7 +4399,7 @@
             <a:r>
               <a:rPr lang="en-US" sz="3200" b="1" dirty="0">
                 <a:solidFill>
-                  <a:schemeClr val="tx1"/>
+                  <a:srgbClr val="2E2E2E"/>
                 </a:solidFill>
               </a:rPr>
               <a:t>Lo que más aumenta el riesgo</a:t>
@@ -4406,11 +4425,11 @@
             </a:avLst>
           </a:prstGeom>
           <a:solidFill>
-            <a:schemeClr val="bg1"/>
+            <a:srgbClr val="FFFFFF"/>
           </a:solidFill>
           <a:ln w="12700">
             <a:solidFill>
-              <a:schemeClr val="bg1"/>
+              <a:srgbClr val="FFFFFF"/>
             </a:solidFill>
             <a:prstDash val="solid"/>
           </a:ln>
@@ -4425,7 +4444,7 @@
       </p:sp>
       <p:pic>
         <p:nvPicPr>
-          <p:cNvPr id="4" name="foto Un solo sector" descr="/tmp/claude-0/-home-user-cedi-d1-lebrija/46e3a16f-f43b-510e-9032-e476e8d715c5/scratchpad/assets/n_mapa.jpg">    </p:cNvPr>
+          <p:cNvPr id="4" name="foto Un solo sector" descr="/tmp/claude-0/-home-user-cedi-d1-lebrija/46e3a16f-f43b-510e-9032-e476e8d715c5/scratchpad/ppt/recortes/n_mapa_2.85x2.9.jpg">    </p:cNvPr>
           <p:cNvPicPr>
             <a:picLocks noChangeAspect="1"/>
           </p:cNvPicPr>
@@ -4433,8 +4452,9 @@
         </p:nvPicPr>
         <p:blipFill>
           <a:blip r:embed="rId1"/>
-          <a:srcRect l="0" r="0" t="0" b="0"/>
-          <a:stretch/>
+          <a:stretch>
+            <a:fillRect/>
+          </a:stretch>
         </p:blipFill>
         <p:spPr>
           <a:xfrm>
@@ -4461,11 +4481,11 @@
             <a:avLst/>
           </a:prstGeom>
           <a:solidFill>
-            <a:schemeClr val="tx2"/>
+            <a:srgbClr val="3B3B3B"/>
           </a:solidFill>
           <a:ln w="25400">
             <a:solidFill>
-              <a:schemeClr val="bg1"/>
+              <a:srgbClr val="FFFFFF"/>
             </a:solidFill>
             <a:prstDash val="solid"/>
           </a:ln>
@@ -4498,7 +4518,7 @@
             <a:r>
               <a:rPr lang="en-US" sz="2400" b="1" dirty="0">
                 <a:solidFill>
-                  <a:schemeClr val="accent1"/>
+                  <a:srgbClr val="CAD225"/>
                 </a:solidFill>
               </a:rPr>
               <a:t>0</a:t>
@@ -4534,7 +4554,7 @@
             <a:r>
               <a:rPr lang="en-US" sz="2000" b="1" dirty="0">
                 <a:solidFill>
-                  <a:schemeClr val="tx1"/>
+                  <a:srgbClr val="2E2E2E"/>
                 </a:solidFill>
               </a:rPr>
               <a:t>Un solo sector</a:t>
@@ -4570,7 +4590,7 @@
             <a:r>
               <a:rPr lang="en-US" sz="1500" dirty="0">
                 <a:solidFill>
-                  <a:schemeClr val="accent6"/>
+                  <a:srgbClr val="5F5F5F"/>
                 </a:solidFill>
               </a:rPr>
               <a:t>17.432 m² sin muros cortafuego</a:t>
@@ -4596,11 +4616,11 @@
             </a:avLst>
           </a:prstGeom>
           <a:solidFill>
-            <a:schemeClr val="bg1"/>
+            <a:srgbClr val="FFFFFF"/>
           </a:solidFill>
           <a:ln w="12700">
             <a:solidFill>
-              <a:schemeClr val="bg1"/>
+              <a:srgbClr val="FFFFFF"/>
             </a:solidFill>
             <a:prstDash val="solid"/>
           </a:ln>
@@ -4615,7 +4635,7 @@
       </p:sp>
       <p:pic>
         <p:nvPicPr>
-          <p:cNvPr id="10" name="foto Almacenamiento alto" descr="/tmp/claude-0/-home-user-cedi-d1-lebrija/46e3a16f-f43b-510e-9032-e476e8d715c5/scratchpad/assets/f_28-2.jpg">    </p:cNvPr>
+          <p:cNvPr id="10" name="foto Almacenamiento alto" descr="/tmp/claude-0/-home-user-cedi-d1-lebrija/46e3a16f-f43b-510e-9032-e476e8d715c5/scratchpad/ppt/recortes/28-2_2.85x2.9.jpg">    </p:cNvPr>
           <p:cNvPicPr>
             <a:picLocks noChangeAspect="1"/>
           </p:cNvPicPr>
@@ -4623,8 +4643,9 @@
         </p:nvPicPr>
         <p:blipFill>
           <a:blip r:embed="rId2"/>
-          <a:srcRect l="0" r="0" t="0" b="0"/>
-          <a:stretch/>
+          <a:stretch>
+            <a:fillRect/>
+          </a:stretch>
         </p:blipFill>
         <p:spPr>
           <a:xfrm>
@@ -4651,11 +4672,11 @@
             <a:avLst/>
           </a:prstGeom>
           <a:solidFill>
-            <a:schemeClr val="tx2"/>
+            <a:srgbClr val="3B3B3B"/>
           </a:solidFill>
           <a:ln w="25400">
             <a:solidFill>
-              <a:schemeClr val="bg1"/>
+              <a:srgbClr val="FFFFFF"/>
             </a:solidFill>
             <a:prstDash val="solid"/>
           </a:ln>
@@ -4688,7 +4709,7 @@
             <a:r>
               <a:rPr lang="en-US" sz="2400" b="1" dirty="0">
                 <a:solidFill>
-                  <a:schemeClr val="accent1"/>
+                  <a:srgbClr val="CAD225"/>
                 </a:solidFill>
               </a:rPr>
               <a:t>0</a:t>
@@ -4724,7 +4745,7 @@
             <a:r>
               <a:rPr lang="en-US" sz="2000" b="1" dirty="0">
                 <a:solidFill>
-                  <a:schemeClr val="tx1"/>
+                  <a:srgbClr val="2E2E2E"/>
                 </a:solidFill>
               </a:rPr>
               <a:t>Almacenamiento alto</a:t>
@@ -4760,7 +4781,7 @@
             <a:r>
               <a:rPr lang="en-US" sz="1500" dirty="0">
                 <a:solidFill>
-                  <a:schemeClr val="accent6"/>
+                  <a:srgbClr val="5F5F5F"/>
                 </a:solidFill>
               </a:rPr>
               <a:t>Estanterías de unos 10 m</a:t>
@@ -4786,11 +4807,11 @@
             </a:avLst>
           </a:prstGeom>
           <a:solidFill>
-            <a:schemeClr val="bg1"/>
+            <a:srgbClr val="FFFFFF"/>
           </a:solidFill>
           <a:ln w="12700">
             <a:solidFill>
-              <a:schemeClr val="bg1"/>
+              <a:srgbClr val="FFFFFF"/>
             </a:solidFill>
             <a:prstDash val="solid"/>
           </a:ln>
@@ -4805,7 +4826,7 @@
       </p:sp>
       <p:pic>
         <p:nvPicPr>
-          <p:cNvPr id="16" name="foto Carga térmica alta" descr="/tmp/claude-0/-home-user-cedi-d1-lebrija/46e3a16f-f43b-510e-9032-e476e8d715c5/scratchpad/assets/f_33-3.jpg">    </p:cNvPr>
+          <p:cNvPr id="16" name="foto Carga térmica alta" descr="/tmp/claude-0/-home-user-cedi-d1-lebrija/46e3a16f-f43b-510e-9032-e476e8d715c5/scratchpad/ppt/recortes/33-3_2.85x2.9.jpg">    </p:cNvPr>
           <p:cNvPicPr>
             <a:picLocks noChangeAspect="1"/>
           </p:cNvPicPr>
@@ -4813,8 +4834,9 @@
         </p:nvPicPr>
         <p:blipFill>
           <a:blip r:embed="rId3"/>
-          <a:srcRect l="0" r="0" t="0" b="0"/>
-          <a:stretch/>
+          <a:stretch>
+            <a:fillRect/>
+          </a:stretch>
         </p:blipFill>
         <p:spPr>
           <a:xfrm>
@@ -4841,11 +4863,11 @@
             <a:avLst/>
           </a:prstGeom>
           <a:solidFill>
-            <a:schemeClr val="tx2"/>
+            <a:srgbClr val="3B3B3B"/>
           </a:solidFill>
           <a:ln w="25400">
             <a:solidFill>
-              <a:schemeClr val="bg1"/>
+              <a:srgbClr val="FFFFFF"/>
             </a:solidFill>
             <a:prstDash val="solid"/>
           </a:ln>
@@ -4878,7 +4900,7 @@
             <a:r>
               <a:rPr lang="en-US" sz="2400" b="1" dirty="0">
                 <a:solidFill>
-                  <a:schemeClr val="accent1"/>
+                  <a:srgbClr val="CAD225"/>
                 </a:solidFill>
               </a:rPr>
               <a:t>0</a:t>
@@ -4914,7 +4936,7 @@
             <a:r>
               <a:rPr lang="en-US" sz="2000" b="1" dirty="0">
                 <a:solidFill>
-                  <a:schemeClr val="tx1"/>
+                  <a:srgbClr val="2E2E2E"/>
                 </a:solidFill>
               </a:rPr>
               <a:t>Carga térmica alta</a:t>
@@ -4950,7 +4972,7 @@
             <a:r>
               <a:rPr lang="en-US" sz="1500" dirty="0">
                 <a:solidFill>
-                  <a:schemeClr val="accent6"/>
+                  <a:srgbClr val="5F5F5F"/>
                 </a:solidFill>
               </a:rPr>
               <a:t>Cartón, plástico y alimentos</a:t>
@@ -4976,11 +4998,11 @@
             </a:avLst>
           </a:prstGeom>
           <a:solidFill>
-            <a:schemeClr val="bg1"/>
+            <a:srgbClr val="FFFFFF"/>
           </a:solidFill>
           <a:ln w="12700">
             <a:solidFill>
-              <a:schemeClr val="bg1"/>
+              <a:srgbClr val="FFFFFF"/>
             </a:solidFill>
             <a:prstDash val="solid"/>
           </a:ln>
@@ -4995,7 +5017,7 @@
       </p:sp>
       <p:pic>
         <p:nvPicPr>
-          <p:cNvPr id="22" name="foto Valor concentrado" descr="/tmp/claude-0/-home-user-cedi-d1-lebrija/46e3a16f-f43b-510e-9032-e476e8d715c5/scratchpad/assets/f_30-1.jpg">    </p:cNvPr>
+          <p:cNvPr id="22" name="foto Valor concentrado" descr="/tmp/claude-0/-home-user-cedi-d1-lebrija/46e3a16f-f43b-510e-9032-e476e8d715c5/scratchpad/ppt/recortes/30-1_2.85x2.9.jpg">    </p:cNvPr>
           <p:cNvPicPr>
             <a:picLocks noChangeAspect="1"/>
           </p:cNvPicPr>
@@ -5003,8 +5025,9 @@
         </p:nvPicPr>
         <p:blipFill>
           <a:blip r:embed="rId4"/>
-          <a:srcRect l="0" r="0" t="0" b="0"/>
-          <a:stretch/>
+          <a:stretch>
+            <a:fillRect/>
+          </a:stretch>
         </p:blipFill>
         <p:spPr>
           <a:xfrm>
@@ -5031,11 +5054,11 @@
             <a:avLst/>
           </a:prstGeom>
           <a:solidFill>
-            <a:schemeClr val="tx2"/>
+            <a:srgbClr val="3B3B3B"/>
           </a:solidFill>
           <a:ln w="25400">
             <a:solidFill>
-              <a:schemeClr val="bg1"/>
+              <a:srgbClr val="FFFFFF"/>
             </a:solidFill>
             <a:prstDash val="solid"/>
           </a:ln>
@@ -5068,7 +5091,7 @@
             <a:r>
               <a:rPr lang="en-US" sz="2400" b="1" dirty="0">
                 <a:solidFill>
-                  <a:schemeClr val="accent1"/>
+                  <a:srgbClr val="CAD225"/>
                 </a:solidFill>
               </a:rPr>
               <a:t>0</a:t>
@@ -5104,7 +5127,7 @@
             <a:r>
               <a:rPr lang="en-US" sz="2000" b="1" dirty="0">
                 <a:solidFill>
-                  <a:schemeClr val="tx1"/>
+                  <a:srgbClr val="2E2E2E"/>
                 </a:solidFill>
               </a:rPr>
               <a:t>Valor concentrado</a:t>
@@ -5140,7 +5163,7 @@
             <a:r>
               <a:rPr lang="en-US" sz="1500" dirty="0">
                 <a:solidFill>
-                  <a:schemeClr val="accent6"/>
+                  <a:srgbClr val="5F5F5F"/>
                 </a:solidFill>
               </a:rPr>
               <a:t>≈ 28,7 millones COP por m²</a:t>
@@ -5179,7 +5202,7 @@
             <a:lvl1pPr>
               <a:defRPr sz="1000">
                 <a:solidFill>
-                  <a:schemeClr val="accent6"/>
+                  <a:srgbClr val="5F5F5F"/>
                 </a:solidFill>
               </a:defRPr>
             </a:lvl1pPr>
@@ -5248,7 +5271,7 @@
             <a:r>
               <a:rPr lang="en-US" sz="3200" b="1" dirty="0">
                 <a:solidFill>
-                  <a:schemeClr val="tx1"/>
+                  <a:srgbClr val="2E2E2E"/>
                 </a:solidFill>
               </a:rPr>
               <a:t>Medios de protección</a:t>
@@ -5284,7 +5307,7 @@
             <a:r>
               <a:rPr lang="en-US" sz="1500" dirty="0">
                 <a:solidFill>
-                  <a:schemeClr val="tx1"/>
+                  <a:srgbClr val="2E2E2E"/>
                 </a:solidFill>
               </a:rPr>
               <a:t>Rociadores automáticos</a:t>
@@ -5310,11 +5333,11 @@
             </a:avLst>
           </a:prstGeom>
           <a:solidFill>
-            <a:schemeClr val="bg2"/>
+            <a:srgbClr val="F4F7D3"/>
           </a:solidFill>
           <a:ln w="12700">
             <a:solidFill>
-              <a:schemeClr val="bg2"/>
+              <a:srgbClr val="F4F7D3"/>
             </a:solidFill>
             <a:prstDash val="solid"/>
           </a:ln>
@@ -5337,11 +5360,11 @@
             </a:avLst>
           </a:prstGeom>
           <a:solidFill>
-            <a:schemeClr val="accent1"/>
+            <a:srgbClr val="CAD225"/>
           </a:solidFill>
           <a:ln w="12700">
             <a:solidFill>
-              <a:schemeClr val="accent1"/>
+              <a:srgbClr val="CAD225"/>
             </a:solidFill>
             <a:prstDash val="solid"/>
           </a:ln>
@@ -5374,7 +5397,7 @@
             <a:r>
               <a:rPr lang="en-US" sz="1600" b="1" dirty="0">
                 <a:solidFill>
-                  <a:schemeClr val="tx1"/>
+                  <a:srgbClr val="2E2E2E"/>
                 </a:solidFill>
               </a:rPr>
               <a:t>8</a:t>
@@ -5410,7 +5433,7 @@
             <a:r>
               <a:rPr lang="en-US" sz="1500" dirty="0">
                 <a:solidFill>
-                  <a:schemeClr val="tx1"/>
+                  <a:srgbClr val="2E2E2E"/>
                 </a:solidFill>
               </a:rPr>
               <a:t>Gabinetes contra incendio (BIE)</a:t>
@@ -5436,11 +5459,11 @@
             </a:avLst>
           </a:prstGeom>
           <a:solidFill>
-            <a:schemeClr val="bg2"/>
+            <a:srgbClr val="F4F7D3"/>
           </a:solidFill>
           <a:ln w="12700">
             <a:solidFill>
-              <a:schemeClr val="bg2"/>
+              <a:srgbClr val="F4F7D3"/>
             </a:solidFill>
             <a:prstDash val="solid"/>
           </a:ln>
@@ -5463,11 +5486,11 @@
             </a:avLst>
           </a:prstGeom>
           <a:solidFill>
-            <a:schemeClr val="accent1"/>
+            <a:srgbClr val="CAD225"/>
           </a:solidFill>
           <a:ln w="12700">
             <a:solidFill>
-              <a:schemeClr val="accent1"/>
+              <a:srgbClr val="CAD225"/>
             </a:solidFill>
             <a:prstDash val="solid"/>
           </a:ln>
@@ -5500,7 +5523,7 @@
             <a:r>
               <a:rPr lang="en-US" sz="1600" b="1" dirty="0">
                 <a:solidFill>
-                  <a:schemeClr val="tx1"/>
+                  <a:srgbClr val="2E2E2E"/>
                 </a:solidFill>
               </a:rPr>
               <a:t>4</a:t>
@@ -5536,7 +5559,7 @@
             <a:r>
               <a:rPr lang="en-US" sz="1500" dirty="0">
                 <a:solidFill>
-                  <a:schemeClr val="tx1"/>
+                  <a:srgbClr val="2E2E2E"/>
                 </a:solidFill>
               </a:rPr>
               <a:t>Hidrante exterior</a:t>
@@ -5562,11 +5585,11 @@
             </a:avLst>
           </a:prstGeom>
           <a:solidFill>
-            <a:schemeClr val="bg2"/>
+            <a:srgbClr val="F4F7D3"/>
           </a:solidFill>
           <a:ln w="12700">
             <a:solidFill>
-              <a:schemeClr val="bg2"/>
+              <a:srgbClr val="F4F7D3"/>
             </a:solidFill>
             <a:prstDash val="solid"/>
           </a:ln>
@@ -5589,11 +5612,11 @@
             </a:avLst>
           </a:prstGeom>
           <a:solidFill>
-            <a:schemeClr val="accent1"/>
+            <a:srgbClr val="CAD225"/>
           </a:solidFill>
           <a:ln w="12700">
             <a:solidFill>
-              <a:schemeClr val="accent1"/>
+              <a:srgbClr val="CAD225"/>
             </a:solidFill>
             <a:prstDash val="solid"/>
           </a:ln>
@@ -5626,7 +5649,7 @@
             <a:r>
               <a:rPr lang="en-US" sz="1600" b="1" dirty="0">
                 <a:solidFill>
-                  <a:schemeClr val="tx1"/>
+                  <a:srgbClr val="2E2E2E"/>
                 </a:solidFill>
               </a:rPr>
               <a:t>4</a:t>
@@ -5662,7 +5685,7 @@
             <a:r>
               <a:rPr lang="en-US" sz="1500" dirty="0">
                 <a:solidFill>
-                  <a:schemeClr val="tx1"/>
+                  <a:srgbClr val="2E2E2E"/>
                 </a:solidFill>
               </a:rPr>
               <a:t>Detección automática</a:t>
@@ -5688,11 +5711,11 @@
             </a:avLst>
           </a:prstGeom>
           <a:solidFill>
-            <a:schemeClr val="bg2"/>
+            <a:srgbClr val="F4F7D3"/>
           </a:solidFill>
           <a:ln w="12700">
             <a:solidFill>
-              <a:schemeClr val="bg2"/>
+              <a:srgbClr val="F4F7D3"/>
             </a:solidFill>
             <a:prstDash val="solid"/>
           </a:ln>
@@ -5715,11 +5738,11 @@
             </a:avLst>
           </a:prstGeom>
           <a:solidFill>
-            <a:schemeClr val="accent1"/>
+            <a:srgbClr val="CAD225"/>
           </a:solidFill>
           <a:ln w="12700">
             <a:solidFill>
-              <a:schemeClr val="accent1"/>
+              <a:srgbClr val="CAD225"/>
             </a:solidFill>
             <a:prstDash val="solid"/>
           </a:ln>
@@ -5752,7 +5775,7 @@
             <a:r>
               <a:rPr lang="en-US" sz="1600" b="1" dirty="0">
                 <a:solidFill>
-                  <a:schemeClr val="tx1"/>
+                  <a:srgbClr val="2E2E2E"/>
                 </a:solidFill>
               </a:rPr>
               <a:t>4</a:t>
@@ -5788,7 +5811,7 @@
             <a:r>
               <a:rPr lang="en-US" sz="1500" dirty="0">
                 <a:solidFill>
-                  <a:schemeClr val="tx1"/>
+                  <a:srgbClr val="2E2E2E"/>
                 </a:solidFill>
               </a:rPr>
               <a:t>Extintores portátiles</a:t>
@@ -5814,11 +5837,11 @@
             </a:avLst>
           </a:prstGeom>
           <a:solidFill>
-            <a:schemeClr val="bg2"/>
+            <a:srgbClr val="F4F7D3"/>
           </a:solidFill>
           <a:ln w="12700">
             <a:solidFill>
-              <a:schemeClr val="bg2"/>
+              <a:srgbClr val="F4F7D3"/>
             </a:solidFill>
             <a:prstDash val="solid"/>
           </a:ln>
@@ -5841,11 +5864,11 @@
             </a:avLst>
           </a:prstGeom>
           <a:solidFill>
-            <a:schemeClr val="accent1"/>
+            <a:srgbClr val="CAD225"/>
           </a:solidFill>
           <a:ln w="12700">
             <a:solidFill>
-              <a:schemeClr val="accent1"/>
+              <a:srgbClr val="CAD225"/>
             </a:solidFill>
             <a:prstDash val="solid"/>
           </a:ln>
@@ -5878,7 +5901,7 @@
             <a:r>
               <a:rPr lang="en-US" sz="1600" b="1" dirty="0">
                 <a:solidFill>
-                  <a:schemeClr val="tx1"/>
+                  <a:srgbClr val="2E2E2E"/>
                 </a:solidFill>
               </a:rPr>
               <a:t>2</a:t>
@@ -5914,7 +5937,7 @@
             <a:r>
               <a:rPr lang="en-US" sz="1500" dirty="0">
                 <a:solidFill>
-                  <a:schemeClr val="tx1"/>
+                  <a:srgbClr val="2E2E2E"/>
                 </a:solidFill>
               </a:rPr>
               <a:t>Agentes gaseosos (no aplica)</a:t>
@@ -5940,11 +5963,11 @@
             </a:avLst>
           </a:prstGeom>
           <a:solidFill>
-            <a:schemeClr val="bg2"/>
+            <a:srgbClr val="F4F7D3"/>
           </a:solidFill>
           <a:ln w="12700">
             <a:solidFill>
-              <a:schemeClr val="bg2"/>
+              <a:srgbClr val="F4F7D3"/>
             </a:solidFill>
             <a:prstDash val="solid"/>
           </a:ln>
@@ -5977,7 +6000,7 @@
             <a:r>
               <a:rPr lang="en-US" sz="1600" b="1" dirty="0">
                 <a:solidFill>
-                  <a:schemeClr val="tx1"/>
+                  <a:srgbClr val="2E2E2E"/>
                 </a:solidFill>
               </a:rPr>
               <a:t>0</a:t>
@@ -6013,7 +6036,7 @@
             <a:r>
               <a:rPr lang="en-US" sz="5400" b="1" dirty="0">
                 <a:solidFill>
-                  <a:schemeClr val="tx1"/>
+                  <a:srgbClr val="2E2E2E"/>
                 </a:solidFill>
               </a:rPr>
               <a:t>22</a:t>
@@ -6024,7 +6047,7 @@
             <a:r>
               <a:rPr lang="en-US" sz="2200" dirty="0">
                 <a:solidFill>
-                  <a:schemeClr val="accent6"/>
+                  <a:srgbClr val="5F5F5F"/>
                 </a:solidFill>
               </a:rPr>
               <a:t> / 26</a:t>
@@ -6041,8 +6064,8 @@
         </p:nvSpPr>
         <p:spPr>
           <a:xfrm>
-            <a:off x="2926080" y="5440680"/>
-            <a:ext cx="4206240" cy="685800"/>
+            <a:off x="2926080" y="5349240"/>
+            <a:ext cx="4206240" cy="868680"/>
           </a:xfrm>
           <a:prstGeom prst="rect">
             <a:avLst/>
@@ -6060,7 +6083,7 @@
             <a:r>
               <a:rPr lang="en-US" sz="1400" dirty="0">
                 <a:solidFill>
-                  <a:schemeClr val="accent6"/>
+                  <a:srgbClr val="5F5F5F"/>
                 </a:solidFill>
               </a:rPr>
               <a:t>Total Y · todo con vigilancia (CV) y mantenimiento</a:t>
@@ -6071,7 +6094,7 @@
       </p:sp>
       <p:pic>
         <p:nvPicPr>
-          <p:cNvPr id="28" name="foto Rociadores bajo la cubierta" descr="/tmp/claude-0/-home-user-cedi-d1-lebrija/46e3a16f-f43b-510e-9032-e476e8d715c5/scratchpad/assets/f_29-2.jpg">    </p:cNvPr>
+          <p:cNvPr id="28" name="foto Rociadores bajo la cubierta" descr="/tmp/claude-0/-home-user-cedi-d1-lebrija/46e3a16f-f43b-510e-9032-e476e8d715c5/scratchpad/ppt/recortes/29-2_2.2x1.6.jpg">    </p:cNvPr>
           <p:cNvPicPr>
             <a:picLocks noChangeAspect="1"/>
           </p:cNvPicPr>
@@ -6079,8 +6102,9 @@
         </p:nvPicPr>
         <p:blipFill>
           <a:blip r:embed="rId1"/>
-          <a:srcRect l="0" r="0" t="0" b="0"/>
-          <a:stretch/>
+          <a:stretch>
+            <a:fillRect/>
+          </a:stretch>
         </p:blipFill>
         <p:spPr>
           <a:xfrm>
@@ -6119,7 +6143,7 @@
             <a:r>
               <a:rPr lang="en-US" sz="1500" b="1" dirty="0">
                 <a:solidFill>
-                  <a:schemeClr val="tx1"/>
+                  <a:srgbClr val="2E2E2E"/>
                 </a:solidFill>
               </a:rPr>
               <a:t>Rociadores bajo la cubierta</a:t>
@@ -6130,7 +6154,7 @@
       </p:sp>
       <p:pic>
         <p:nvPicPr>
-          <p:cNvPr id="30" name="foto Gabinete contra incendio" descr="/tmp/claude-0/-home-user-cedi-d1-lebrija/46e3a16f-f43b-510e-9032-e476e8d715c5/scratchpad/assets/n_gab.jpg">    </p:cNvPr>
+          <p:cNvPr id="30" name="foto Gabinete contra incendio" descr="/tmp/claude-0/-home-user-cedi-d1-lebrija/46e3a16f-f43b-510e-9032-e476e8d715c5/scratchpad/ppt/recortes/n_gab_2.2x1.6.jpg">    </p:cNvPr>
           <p:cNvPicPr>
             <a:picLocks noChangeAspect="1"/>
           </p:cNvPicPr>
@@ -6138,8 +6162,9 @@
         </p:nvPicPr>
         <p:blipFill>
           <a:blip r:embed="rId2"/>
-          <a:srcRect l="0" r="0" t="0" b="0"/>
-          <a:stretch/>
+          <a:stretch>
+            <a:fillRect/>
+          </a:stretch>
         </p:blipFill>
         <p:spPr>
           <a:xfrm>
@@ -6178,7 +6203,7 @@
             <a:r>
               <a:rPr lang="en-US" sz="1500" b="1" dirty="0">
                 <a:solidFill>
-                  <a:schemeClr val="tx1"/>
+                  <a:srgbClr val="2E2E2E"/>
                 </a:solidFill>
               </a:rPr>
               <a:t>Gabinete contra incendio</a:t>
@@ -6189,7 +6214,7 @@
       </p:sp>
       <p:pic>
         <p:nvPicPr>
-          <p:cNvPr id="32" name="foto Hidrante exterior" descr="/tmp/claude-0/-home-user-cedi-d1-lebrija/46e3a16f-f43b-510e-9032-e476e8d715c5/scratchpad/assets/n_hidrante.jpg">    </p:cNvPr>
+          <p:cNvPr id="32" name="foto Hidrante exterior" descr="/tmp/claude-0/-home-user-cedi-d1-lebrija/46e3a16f-f43b-510e-9032-e476e8d715c5/scratchpad/ppt/recortes/n_hidrante_2.2x1.6.jpg">    </p:cNvPr>
           <p:cNvPicPr>
             <a:picLocks noChangeAspect="1"/>
           </p:cNvPicPr>
@@ -6197,8 +6222,9 @@
         </p:nvPicPr>
         <p:blipFill>
           <a:blip r:embed="rId3"/>
-          <a:srcRect l="0" r="0" t="0" b="0"/>
-          <a:stretch/>
+          <a:stretch>
+            <a:fillRect/>
+          </a:stretch>
         </p:blipFill>
         <p:spPr>
           <a:xfrm>
@@ -6237,7 +6263,7 @@
             <a:r>
               <a:rPr lang="en-US" sz="1500" b="1" dirty="0">
                 <a:solidFill>
-                  <a:schemeClr val="tx1"/>
+                  <a:srgbClr val="2E2E2E"/>
                 </a:solidFill>
               </a:rPr>
               <a:t>Hidrante exterior</a:t>
@@ -6276,7 +6302,7 @@
             <a:lvl1pPr>
               <a:defRPr sz="1000">
                 <a:solidFill>
-                  <a:schemeClr val="accent6"/>
+                  <a:srgbClr val="5F5F5F"/>
                 </a:solidFill>
               </a:defRPr>
             </a:lvl1pPr>
@@ -6345,7 +6371,7 @@
             <a:r>
               <a:rPr lang="en-US" sz="3200" b="1" dirty="0">
                 <a:solidFill>
-                  <a:schemeClr val="tx1"/>
+                  <a:srgbClr val="2E2E2E"/>
                 </a:solidFill>
               </a:rPr>
               <a:t>Resultado: coeficiente de protección P</a:t>
@@ -6369,11 +6395,11 @@
             <a:avLst/>
           </a:prstGeom>
           <a:solidFill>
-            <a:schemeClr val="accent1"/>
+            <a:srgbClr val="CAD225"/>
           </a:solidFill>
           <a:ln w="12700">
             <a:solidFill>
-              <a:schemeClr val="accent1"/>
+              <a:srgbClr val="CAD225"/>
             </a:solidFill>
             <a:prstDash val="solid"/>
           </a:ln>
@@ -6406,7 +6432,7 @@
             <a:r>
               <a:rPr lang="en-US" sz="2000" b="1" dirty="0">
                 <a:solidFill>
-                  <a:schemeClr val="tx1"/>
+                  <a:srgbClr val="2E2E2E"/>
                 </a:solidFill>
               </a:rPr>
               <a:t>1</a:t>
@@ -6442,7 +6468,7 @@
             <a:r>
               <a:rPr lang="en-US" sz="1400" dirty="0">
                 <a:solidFill>
-                  <a:schemeClr val="accent6"/>
+                  <a:srgbClr val="5F5F5F"/>
                 </a:solidFill>
               </a:rPr>
               <a:t>Fórmula</a:t>
@@ -6456,7 +6482,7 @@
             <a:r>
               <a:rPr lang="en-US" sz="2200" b="1" dirty="0">
                 <a:solidFill>
-                  <a:schemeClr val="tx1"/>
+                  <a:srgbClr val="2E2E2E"/>
                 </a:solidFill>
               </a:rPr>
               <a:t>P = 5X / 129 + 5Y / 26 + BCI</a:t>
@@ -6480,11 +6506,11 @@
             <a:avLst/>
           </a:prstGeom>
           <a:solidFill>
-            <a:schemeClr val="accent1"/>
+            <a:srgbClr val="CAD225"/>
           </a:solidFill>
           <a:ln w="12700">
             <a:solidFill>
-              <a:schemeClr val="accent1"/>
+              <a:srgbClr val="CAD225"/>
             </a:solidFill>
             <a:prstDash val="solid"/>
           </a:ln>
@@ -6517,7 +6543,7 @@
             <a:r>
               <a:rPr lang="en-US" sz="2000" b="1" dirty="0">
                 <a:solidFill>
-                  <a:schemeClr val="tx1"/>
+                  <a:srgbClr val="2E2E2E"/>
                 </a:solidFill>
               </a:rPr>
               <a:t>2</a:t>
@@ -6553,7 +6579,7 @@
             <a:r>
               <a:rPr lang="en-US" sz="1400" dirty="0">
                 <a:solidFill>
-                  <a:schemeClr val="accent6"/>
+                  <a:srgbClr val="5F5F5F"/>
                 </a:solidFill>
               </a:rPr>
               <a:t>Reemplazo</a:t>
@@ -6567,7 +6593,7 @@
             <a:r>
               <a:rPr lang="en-US" sz="2200" b="1" dirty="0">
                 <a:solidFill>
-                  <a:schemeClr val="tx1"/>
+                  <a:srgbClr val="2E2E2E"/>
                 </a:solidFill>
               </a:rPr>
               <a:t>P = 5(57) / 129 + 5(22) / 26 + 0</a:t>
@@ -6591,11 +6617,11 @@
             <a:avLst/>
           </a:prstGeom>
           <a:solidFill>
-            <a:schemeClr val="accent1"/>
+            <a:srgbClr val="CAD225"/>
           </a:solidFill>
           <a:ln w="12700">
             <a:solidFill>
-              <a:schemeClr val="accent1"/>
+              <a:srgbClr val="CAD225"/>
             </a:solidFill>
             <a:prstDash val="solid"/>
           </a:ln>
@@ -6628,7 +6654,7 @@
             <a:r>
               <a:rPr lang="en-US" sz="2000" b="1" dirty="0">
                 <a:solidFill>
-                  <a:schemeClr val="tx1"/>
+                  <a:srgbClr val="2E2E2E"/>
                 </a:solidFill>
               </a:rPr>
               <a:t>3</a:t>
@@ -6664,7 +6690,7 @@
             <a:r>
               <a:rPr lang="en-US" sz="1400" dirty="0">
                 <a:solidFill>
-                  <a:schemeClr val="accent6"/>
+                  <a:srgbClr val="5F5F5F"/>
                 </a:solidFill>
               </a:rPr>
               <a:t>Operación</a:t>
@@ -6678,7 +6704,7 @@
             <a:r>
               <a:rPr lang="en-US" sz="2200" b="1" dirty="0">
                 <a:solidFill>
-                  <a:schemeClr val="tx1"/>
+                  <a:srgbClr val="2E2E2E"/>
                 </a:solidFill>
               </a:rPr>
               <a:t>P = 2,209 + 4,231 + 0</a:t>
@@ -6714,7 +6740,7 @@
             <a:r>
               <a:rPr lang="en-US" sz="1500" i="1" dirty="0">
                 <a:solidFill>
-                  <a:schemeClr val="accent6"/>
+                  <a:srgbClr val="5F5F5F"/>
                 </a:solidFill>
               </a:rPr>
               <a:t>La brigada (BCI) vale 0: el CEDI no tiene brigada contra incendios.</a:t>
@@ -6738,11 +6764,11 @@
             <a:avLst/>
           </a:prstGeom>
           <a:solidFill>
-            <a:schemeClr val="accent1"/>
+            <a:srgbClr val="CAD225"/>
           </a:solidFill>
           <a:ln w="12700">
             <a:solidFill>
-              <a:schemeClr val="accent1"/>
+              <a:srgbClr val="CAD225"/>
             </a:solidFill>
             <a:prstDash val="solid"/>
           </a:ln>
@@ -6782,7 +6808,7 @@
             <a:r>
               <a:rPr lang="en-US" sz="2200" dirty="0">
                 <a:solidFill>
-                  <a:schemeClr val="tx1"/>
+                  <a:srgbClr val="2E2E2E"/>
                 </a:solidFill>
               </a:rPr>
               <a:t>P =</a:t>
@@ -6796,7 +6822,7 @@
             <a:r>
               <a:rPr lang="en-US" sz="6600" b="1" dirty="0">
                 <a:solidFill>
-                  <a:schemeClr val="tx1"/>
+                  <a:srgbClr val="2E2E2E"/>
                 </a:solidFill>
               </a:rPr>
               <a:t>6,44</a:t>
@@ -6810,7 +6836,7 @@
             <a:r>
               <a:rPr lang="en-US" sz="2000" b="1" dirty="0">
                 <a:solidFill>
-                  <a:schemeClr val="tx1"/>
+                  <a:srgbClr val="2E2E2E"/>
                 </a:solidFill>
               </a:rPr>
               <a:t>Riesgo bueno</a:t>
@@ -6834,11 +6860,11 @@
             <a:avLst/>
           </a:prstGeom>
           <a:solidFill>
-            <a:schemeClr val="accent3"/>
+            <a:srgbClr val="E8836F"/>
           </a:solidFill>
           <a:ln w="12700">
             <a:solidFill>
-              <a:schemeClr val="bg1"/>
+              <a:srgbClr val="FFFFFF"/>
             </a:solidFill>
             <a:prstDash val="solid"/>
           </a:ln>
@@ -6871,7 +6897,7 @@
             <a:r>
               <a:rPr lang="en-US" sz="1300" dirty="0">
                 <a:solidFill>
-                  <a:schemeClr val="tx1"/>
+                  <a:srgbClr val="2E2E2E"/>
                 </a:solidFill>
               </a:rPr>
               <a:t>Muy malo</a:t>
@@ -6895,11 +6921,11 @@
             <a:avLst/>
           </a:prstGeom>
           <a:solidFill>
-            <a:schemeClr val="accent4"/>
+            <a:srgbClr val="F2B76B"/>
           </a:solidFill>
           <a:ln w="12700">
             <a:solidFill>
-              <a:schemeClr val="bg1"/>
+              <a:srgbClr val="FFFFFF"/>
             </a:solidFill>
             <a:prstDash val="solid"/>
           </a:ln>
@@ -6932,7 +6958,7 @@
             <a:r>
               <a:rPr lang="en-US" sz="1300" dirty="0">
                 <a:solidFill>
-                  <a:schemeClr val="tx1"/>
+                  <a:srgbClr val="2E2E2E"/>
                 </a:solidFill>
               </a:rPr>
               <a:t>Malo</a:t>
@@ -6956,11 +6982,11 @@
             <a:avLst/>
           </a:prstGeom>
           <a:solidFill>
-            <a:schemeClr val="bg2"/>
+            <a:srgbClr val="F4F7D3"/>
           </a:solidFill>
           <a:ln w="12700">
             <a:solidFill>
-              <a:schemeClr val="bg1"/>
+              <a:srgbClr val="FFFFFF"/>
             </a:solidFill>
             <a:prstDash val="solid"/>
           </a:ln>
@@ -6993,7 +7019,7 @@
             <a:r>
               <a:rPr lang="en-US" sz="1300" dirty="0">
                 <a:solidFill>
-                  <a:schemeClr val="tx1"/>
+                  <a:srgbClr val="2E2E2E"/>
                 </a:solidFill>
               </a:rPr>
               <a:t>Bueno</a:t>
@@ -7017,11 +7043,11 @@
             <a:avLst/>
           </a:prstGeom>
           <a:solidFill>
-            <a:schemeClr val="accent1"/>
+            <a:srgbClr val="CAD225"/>
           </a:solidFill>
           <a:ln w="12700">
             <a:solidFill>
-              <a:schemeClr val="bg1"/>
+              <a:srgbClr val="FFFFFF"/>
             </a:solidFill>
             <a:prstDash val="solid"/>
           </a:ln>
@@ -7054,7 +7080,7 @@
             <a:r>
               <a:rPr lang="en-US" sz="1300" dirty="0">
                 <a:solidFill>
-                  <a:schemeClr val="tx1"/>
+                  <a:srgbClr val="2E2E2E"/>
                 </a:solidFill>
               </a:rPr>
               <a:t>Muy bueno</a:t>
@@ -7078,11 +7104,11 @@
             <a:avLst/>
           </a:prstGeom>
           <a:solidFill>
-            <a:schemeClr val="tx2"/>
+            <a:srgbClr val="3B3B3B"/>
           </a:solidFill>
           <a:ln w="12700">
             <a:solidFill>
-              <a:schemeClr val="tx2"/>
+              <a:srgbClr val="3B3B3B"/>
             </a:solidFill>
             <a:prstDash val="solid"/>
           </a:ln>
@@ -7115,7 +7141,7 @@
             <a:r>
               <a:rPr lang="en-US" sz="1100" dirty="0">
                 <a:solidFill>
-                  <a:schemeClr val="accent6"/>
+                  <a:srgbClr val="5F5F5F"/>
                 </a:solidFill>
               </a:rPr>
               <a:t>0</a:t>
@@ -7151,7 +7177,7 @@
             <a:r>
               <a:rPr lang="en-US" sz="1100" dirty="0">
                 <a:solidFill>
-                  <a:schemeClr val="accent6"/>
+                  <a:srgbClr val="5F5F5F"/>
                 </a:solidFill>
               </a:rPr>
               <a:t>10</a:t>
@@ -7190,7 +7216,7 @@
             <a:lvl1pPr>
               <a:defRPr sz="1000">
                 <a:solidFill>
-                  <a:schemeClr val="accent6"/>
+                  <a:srgbClr val="5F5F5F"/>
                 </a:solidFill>
               </a:defRPr>
             </a:lvl1pPr>
@@ -7259,7 +7285,7 @@
             <a:r>
               <a:rPr lang="en-US" sz="3200" b="1" dirty="0">
                 <a:solidFill>
-                  <a:schemeClr val="bg1"/>
+                  <a:srgbClr val="FFFFFF"/>
                 </a:solidFill>
               </a:rPr>
               <a:t>Conclusión y recomendaciones</a:t>
@@ -7295,7 +7321,7 @@
             <a:r>
               <a:rPr lang="en-US" sz="2000" dirty="0">
                 <a:solidFill>
-                  <a:schemeClr val="bg1"/>
+                  <a:srgbClr val="FFFFFF"/>
                 </a:solidFill>
               </a:rPr>
               <a:t>El edificio tiene condiciones de riesgo altas, pero sus sistemas de protección las compensan: el CEDI queda en riesgo bueno (P = 6,44).</a:t>
@@ -7346,11 +7372,11 @@
             <a:avLst/>
           </a:prstGeom>
           <a:solidFill>
-            <a:schemeClr val="accent1"/>
+            <a:srgbClr val="CAD225"/>
           </a:solidFill>
           <a:ln w="12700">
             <a:solidFill>
-              <a:schemeClr val="accent1"/>
+              <a:srgbClr val="CAD225"/>
             </a:solidFill>
             <a:prstDash val="solid"/>
           </a:ln>
@@ -7407,7 +7433,7 @@
             <a:r>
               <a:rPr lang="en-US" sz="2000" b="1" dirty="0">
                 <a:solidFill>
-                  <a:schemeClr val="bg1"/>
+                  <a:srgbClr val="FFFFFF"/>
                 </a:solidFill>
               </a:rPr>
               <a:t>Conformar una brigada</a:t>
@@ -7494,11 +7520,11 @@
             <a:avLst/>
           </a:prstGeom>
           <a:solidFill>
-            <a:schemeClr val="accent1"/>
+            <a:srgbClr val="CAD225"/>
           </a:solidFill>
           <a:ln w="12700">
             <a:solidFill>
-              <a:schemeClr val="accent1"/>
+              <a:srgbClr val="CAD225"/>
             </a:solidFill>
             <a:prstDash val="solid"/>
           </a:ln>
@@ -7555,7 +7581,7 @@
             <a:r>
               <a:rPr lang="en-US" sz="2000" b="1" dirty="0">
                 <a:solidFill>
-                  <a:schemeClr val="bg1"/>
+                  <a:srgbClr val="FFFFFF"/>
                 </a:solidFill>
               </a:rPr>
               <a:t>Mantener los sistemas</a:t>
@@ -7642,11 +7668,11 @@
             <a:avLst/>
           </a:prstGeom>
           <a:solidFill>
-            <a:schemeClr val="accent1"/>
+            <a:srgbClr val="CAD225"/>
           </a:solidFill>
           <a:ln w="12700">
             <a:solidFill>
-              <a:schemeClr val="accent1"/>
+              <a:srgbClr val="CAD225"/>
             </a:solidFill>
             <a:prstDash val="solid"/>
           </a:ln>
@@ -7703,7 +7729,7 @@
             <a:r>
               <a:rPr lang="en-US" sz="2000" b="1" dirty="0">
                 <a:solidFill>
-                  <a:schemeClr val="bg1"/>
+                  <a:srgbClr val="FFFFFF"/>
                 </a:solidFill>
               </a:rPr>
               <a:t>Corregir el cableado</a:t>
@@ -7775,7 +7801,7 @@
             <a:r>
               <a:rPr lang="en-US" sz="2400" b="1" dirty="0">
                 <a:solidFill>
-                  <a:schemeClr val="accent1"/>
+                  <a:srgbClr val="CAD225"/>
                 </a:solidFill>
               </a:rPr>
               <a:t>¡Gracias!</a:t>
@@ -7814,7 +7840,7 @@
             <a:lvl1pPr>
               <a:defRPr sz="1000">
                 <a:solidFill>
-                  <a:schemeClr val="accent1"/>
+                  <a:srgbClr val="CAD225"/>
                 </a:solidFill>
               </a:defRPr>
             </a:lvl1pPr>

</xml_diff>